<commit_message>
Add Point and ask to the deck and README
</commit_message>
<xml_diff>
--- a/deck/work/Timbul - AI Builder Cup.pptx
+++ b/deck/work/Timbul - AI Builder Cup.pptx
@@ -8375,7 +8375,7 @@
                 </a:solidFill>
                 <a:latin typeface="Google Sans Flex"/>
               </a:rPr>
-              <a:t>about 30 s</a:t>
+              <a:t>4 of 4</a:t>
             </a:r>
           </a:p>
         </p:txBody>
@@ -8389,6 +8389,128 @@
         <p:spPr>
           <a:xfrm>
             <a:off x="457200" y="1783080"/>
+            <a:ext cx="3840480" cy="548640"/>
+          </a:xfrm>
+          <a:prstGeom prst="rect">
+            <a:avLst/>
+          </a:prstGeom>
+          <a:noFill/>
+        </p:spPr>
+        <p:txBody>
+          <a:bodyPr wrap="square" lIns="36576" rIns="36576" tIns="18288" bIns="18288" anchor="t">
+            <a:spAutoFit/>
+          </a:bodyPr>
+          <a:lstStyle/>
+          <a:p>
+            <a:pPr algn="l">
+              <a:spcAft>
+                <a:spcPts val="400"/>
+              </a:spcAft>
+            </a:pPr>
+            <a:r>
+              <a:rPr sz="1000" b="0" i="0">
+                <a:solidFill>
+                  <a:srgbClr val="000000"/>
+                </a:solidFill>
+                <a:latin typeface="Google Sans Flex"/>
+              </a:rPr>
+              <a:t>Point and ask photos answered correctly: two parts, the same photo upside down, and no finger (7 to 21 s each; test photos were generated, not a real printed sheet)</a:t>
+            </a:r>
+          </a:p>
+        </p:txBody>
+      </p:sp>
+      <p:sp>
+        <p:nvSpPr>
+          <p:cNvPr id="147" name="Rounded Rectangle 146"/>
+          <p:cNvSpPr/>
+          <p:nvPr/>
+        </p:nvSpPr>
+        <p:spPr>
+          <a:xfrm>
+            <a:off x="4617720" y="1234440"/>
+            <a:ext cx="4114800" cy="1097280"/>
+          </a:xfrm>
+          <a:prstGeom prst="roundRect">
+            <a:avLst>
+              <a:gd name="adj" fmla="val 12000"/>
+            </a:avLst>
+          </a:prstGeom>
+          <a:solidFill>
+            <a:srgbClr val="FFCC00"/>
+          </a:solidFill>
+          <a:ln>
+            <a:noFill/>
+          </a:ln>
+          <a:effectLst/>
+        </p:spPr>
+        <p:style>
+          <a:lnRef idx="1">
+            <a:schemeClr val="accent1"/>
+          </a:lnRef>
+          <a:fillRef idx="3">
+            <a:schemeClr val="accent1"/>
+          </a:fillRef>
+          <a:effectRef idx="2">
+            <a:schemeClr val="accent1"/>
+          </a:effectRef>
+          <a:fontRef idx="minor">
+            <a:schemeClr val="lt1"/>
+          </a:fontRef>
+        </p:style>
+        <p:txBody>
+          <a:bodyPr rtlCol="0" anchor="ctr"/>
+          <a:lstStyle/>
+          <a:p/>
+        </p:txBody>
+      </p:sp>
+      <p:sp>
+        <p:nvSpPr>
+          <p:cNvPr id="148" name="TextBox 147"/>
+          <p:cNvSpPr txBox="1"/>
+          <p:nvPr/>
+        </p:nvSpPr>
+        <p:spPr>
+          <a:xfrm>
+            <a:off x="4754880" y="1307592"/>
+            <a:ext cx="3840480" cy="457200"/>
+          </a:xfrm>
+          <a:prstGeom prst="rect">
+            <a:avLst/>
+          </a:prstGeom>
+          <a:noFill/>
+        </p:spPr>
+        <p:txBody>
+          <a:bodyPr wrap="square" lIns="36576" rIns="36576" tIns="18288" bIns="18288" anchor="t">
+            <a:spAutoFit/>
+          </a:bodyPr>
+          <a:lstStyle/>
+          <a:p>
+            <a:pPr algn="l">
+              <a:spcAft>
+                <a:spcPts val="400"/>
+              </a:spcAft>
+            </a:pPr>
+            <a:r>
+              <a:rPr sz="2200" b="1" i="0">
+                <a:solidFill>
+                  <a:srgbClr val="000000"/>
+                </a:solidFill>
+                <a:latin typeface="Google Sans Flex"/>
+              </a:rPr>
+              <a:t>about 30 s</a:t>
+            </a:r>
+          </a:p>
+        </p:txBody>
+      </p:sp>
+      <p:sp>
+        <p:nvSpPr>
+          <p:cNvPr id="149" name="TextBox 148"/>
+          <p:cNvSpPr txBox="1"/>
+          <p:nvPr/>
+        </p:nvSpPr>
+        <p:spPr>
+          <a:xfrm>
+            <a:off x="4754880" y="1783080"/>
             <a:ext cx="3840480" cy="548640"/>
           </a:xfrm>
           <a:prstGeom prst="rect">
@@ -8421,13 +8543,13 @@
       </p:sp>
       <p:sp>
         <p:nvSpPr>
-          <p:cNvPr id="147" name="Rounded Rectangle 146"/>
+          <p:cNvPr id="150" name="Rounded Rectangle 149"/>
           <p:cNvSpPr/>
           <p:nvPr/>
         </p:nvSpPr>
         <p:spPr>
           <a:xfrm>
-            <a:off x="4617720" y="1234440"/>
+            <a:off x="320040" y="2468880"/>
             <a:ext cx="4114800" cy="1097280"/>
           </a:xfrm>
           <a:prstGeom prst="roundRect">
@@ -8465,13 +8587,13 @@
       </p:sp>
       <p:sp>
         <p:nvSpPr>
-          <p:cNvPr id="148" name="TextBox 147"/>
+          <p:cNvPr id="151" name="TextBox 150"/>
           <p:cNvSpPr txBox="1"/>
           <p:nvPr/>
         </p:nvSpPr>
         <p:spPr>
           <a:xfrm>
-            <a:off x="4754880" y="1307592"/>
+            <a:off x="457200" y="2542032"/>
             <a:ext cx="3840480" cy="457200"/>
           </a:xfrm>
           <a:prstGeom prst="rect">
@@ -8504,13 +8626,13 @@
       </p:sp>
       <p:sp>
         <p:nvSpPr>
-          <p:cNvPr id="149" name="TextBox 148"/>
+          <p:cNvPr id="152" name="TextBox 151"/>
           <p:cNvSpPr txBox="1"/>
           <p:nvPr/>
         </p:nvSpPr>
         <p:spPr>
           <a:xfrm>
-            <a:off x="4754880" y="1783080"/>
+            <a:off x="457200" y="3017520"/>
             <a:ext cx="3840480" cy="548640"/>
           </a:xfrm>
           <a:prstGeom prst="rect">
@@ -8543,13 +8665,13 @@
       </p:sp>
       <p:sp>
         <p:nvSpPr>
-          <p:cNvPr id="150" name="Rounded Rectangle 149"/>
+          <p:cNvPr id="153" name="Rounded Rectangle 152"/>
           <p:cNvSpPr/>
           <p:nvPr/>
         </p:nvSpPr>
         <p:spPr>
           <a:xfrm>
-            <a:off x="320040" y="2468880"/>
+            <a:off x="4617720" y="2468880"/>
             <a:ext cx="4114800" cy="1097280"/>
           </a:xfrm>
           <a:prstGeom prst="roundRect">
@@ -8587,13 +8709,13 @@
       </p:sp>
       <p:sp>
         <p:nvSpPr>
-          <p:cNvPr id="151" name="TextBox 150"/>
+          <p:cNvPr id="154" name="TextBox 153"/>
           <p:cNvSpPr txBox="1"/>
           <p:nvPr/>
         </p:nvSpPr>
         <p:spPr>
           <a:xfrm>
-            <a:off x="457200" y="2542032"/>
+            <a:off x="4754880" y="2542032"/>
             <a:ext cx="3840480" cy="457200"/>
           </a:xfrm>
           <a:prstGeom prst="rect">
@@ -8626,13 +8748,13 @@
       </p:sp>
       <p:sp>
         <p:nvSpPr>
-          <p:cNvPr id="152" name="TextBox 151"/>
+          <p:cNvPr id="155" name="TextBox 154"/>
           <p:cNvSpPr txBox="1"/>
           <p:nvPr/>
         </p:nvSpPr>
         <p:spPr>
           <a:xfrm>
-            <a:off x="457200" y="3017520"/>
+            <a:off x="4754880" y="3017520"/>
             <a:ext cx="3840480" cy="548640"/>
           </a:xfrm>
           <a:prstGeom prst="rect">
@@ -8665,128 +8787,6 @@
       </p:sp>
       <p:sp>
         <p:nvSpPr>
-          <p:cNvPr id="153" name="Rounded Rectangle 152"/>
-          <p:cNvSpPr/>
-          <p:nvPr/>
-        </p:nvSpPr>
-        <p:spPr>
-          <a:xfrm>
-            <a:off x="4617720" y="2468880"/>
-            <a:ext cx="4114800" cy="1097280"/>
-          </a:xfrm>
-          <a:prstGeom prst="roundRect">
-            <a:avLst>
-              <a:gd name="adj" fmla="val 12000"/>
-            </a:avLst>
-          </a:prstGeom>
-          <a:solidFill>
-            <a:srgbClr val="FFCC00"/>
-          </a:solidFill>
-          <a:ln>
-            <a:noFill/>
-          </a:ln>
-          <a:effectLst/>
-        </p:spPr>
-        <p:style>
-          <a:lnRef idx="1">
-            <a:schemeClr val="accent1"/>
-          </a:lnRef>
-          <a:fillRef idx="3">
-            <a:schemeClr val="accent1"/>
-          </a:fillRef>
-          <a:effectRef idx="2">
-            <a:schemeClr val="accent1"/>
-          </a:effectRef>
-          <a:fontRef idx="minor">
-            <a:schemeClr val="lt1"/>
-          </a:fontRef>
-        </p:style>
-        <p:txBody>
-          <a:bodyPr rtlCol="0" anchor="ctr"/>
-          <a:lstStyle/>
-          <a:p/>
-        </p:txBody>
-      </p:sp>
-      <p:sp>
-        <p:nvSpPr>
-          <p:cNvPr id="154" name="TextBox 153"/>
-          <p:cNvSpPr txBox="1"/>
-          <p:nvPr/>
-        </p:nvSpPr>
-        <p:spPr>
-          <a:xfrm>
-            <a:off x="4754880" y="2542032"/>
-            <a:ext cx="3840480" cy="457200"/>
-          </a:xfrm>
-          <a:prstGeom prst="rect">
-            <a:avLst/>
-          </a:prstGeom>
-          <a:noFill/>
-        </p:spPr>
-        <p:txBody>
-          <a:bodyPr wrap="square" lIns="36576" rIns="36576" tIns="18288" bIns="18288" anchor="t">
-            <a:spAutoFit/>
-          </a:bodyPr>
-          <a:lstStyle/>
-          <a:p>
-            <a:pPr algn="l">
-              <a:spcAft>
-                <a:spcPts val="400"/>
-              </a:spcAft>
-            </a:pPr>
-            <a:r>
-              <a:rPr sz="2200" b="1" i="0">
-                <a:solidFill>
-                  <a:srgbClr val="000000"/>
-                </a:solidFill>
-                <a:latin typeface="Google Sans Flex"/>
-              </a:rPr>
-              <a:t>2 to 7 s</a:t>
-            </a:r>
-          </a:p>
-        </p:txBody>
-      </p:sp>
-      <p:sp>
-        <p:nvSpPr>
-          <p:cNvPr id="155" name="TextBox 154"/>
-          <p:cNvSpPr txBox="1"/>
-          <p:nvPr/>
-        </p:nvSpPr>
-        <p:spPr>
-          <a:xfrm>
-            <a:off x="4754880" y="3017520"/>
-            <a:ext cx="3840480" cy="548640"/>
-          </a:xfrm>
-          <a:prstGeom prst="rect">
-            <a:avLst/>
-          </a:prstGeom>
-          <a:noFill/>
-        </p:spPr>
-        <p:txBody>
-          <a:bodyPr wrap="square" lIns="36576" rIns="36576" tIns="18288" bIns="18288" anchor="t">
-            <a:spAutoFit/>
-          </a:bodyPr>
-          <a:lstStyle/>
-          <a:p>
-            <a:pPr algn="l">
-              <a:spcAft>
-                <a:spcPts val="400"/>
-              </a:spcAft>
-            </a:pPr>
-            <a:r>
-              <a:rPr sz="1000" b="0" i="0">
-                <a:solidFill>
-                  <a:srgbClr val="000000"/>
-                </a:solidFill>
-                <a:latin typeface="Google Sans Flex"/>
-              </a:rPr>
-              <a:t>from the end of a spoken question to Gemini's answer; replaying a cached spoken line takes no time</a:t>
-            </a:r>
-          </a:p>
-        </p:txBody>
-      </p:sp>
-      <p:sp>
-        <p:nvSpPr>
           <p:cNvPr id="156" name="TextBox 155"/>
           <p:cNvSpPr txBox="1"/>
           <p:nvPr/>
@@ -8828,7 +8828,7 @@
                 </a:solidFill>
                 <a:latin typeface="Google Sans Flex"/>
               </a:rPr>
-              <a:t>our own runs on 14 and 15 October 2026: a textbook page with an openly licensed plant cell figure, a series circuit, a neural-network diagram and the USGS water cycle, using scripts/check-reading.mjs in the repository.</a:t>
+              <a:t>our own runs on 14 and 15 October 2026: a textbook page with an openly licensed plant cell figure, a series circuit, a neural-network diagram and the USGS water cycle, using scripts/check-reading.mjs and scripts/check-point.mjs in the repository.</a:t>
             </a:r>
           </a:p>
           <a:p>
@@ -9120,7 +9120,7 @@
                 </a:solidFill>
                 <a:latin typeface="Google Sans Flex"/>
               </a:rPr>
-              <a:t>Point and ask: </a:t>
+              <a:t>Point and ask on real sheets: </a:t>
             </a:r>
             <a:r>
               <a:rPr sz="1100" b="0" i="0">
@@ -9129,7 +9129,7 @@
                 </a:solidFill>
                 <a:latin typeface="Google Sans Flex"/>
               </a:rPr>
-              <a:t>A phone above the sheet: the student touches a raised shape and asks “what is this?”; Gemini finds the fingertip and Timbul names the part under it.</a:t>
+              <a:t>It works on photos today; next, a phone stand and tests with printed swell-paper sheets and real fingers, then live video instead of a photo.</a:t>
             </a:r>
           </a:p>
         </p:txBody>
@@ -9221,7 +9221,7 @@
                 </a:solidFill>
                 <a:latin typeface="Google Sans Flex"/>
               </a:rPr>
-              <a:t>Phone view for screen readers: </a:t>
+              <a:t>A phone screen built for screen readers: </a:t>
             </a:r>
             <a:r>
               <a:rPr sz="1100" b="0" i="0">
@@ -9230,7 +9230,7 @@
                 </a:solidFill>
                 <a:latin typeface="Google Sans Flex"/>
               </a:rPr>
-              <a:t>Swipe through parts with VoiceOver or TalkBack, one large Ask button, everything usable with the screen off.</a:t>
+              <a:t>VoiceOver and TalkBack can already swipe through every part; next, a one-button screen for asking and pointing, usable with the screen off.</a:t>
             </a:r>
           </a:p>
         </p:txBody>
@@ -12513,7 +12513,7 @@
                 </a:solidFill>
                 <a:latin typeface="Google Sans Flex"/>
               </a:rPr>
-              <a:t>Approved sheets are numbered and shared by class code (Firestore), so a sheet made on a laptop opens on a phone.</a:t>
+              <a:t>Approved sheets are numbered and shared by class code (Firestore). The student says “sheet two” to open one on any device.</a:t>
             </a:r>
           </a:p>
         </p:txBody>
@@ -12651,7 +12651,7 @@
                 </a:solidFill>
                 <a:latin typeface="Google Sans Flex"/>
               </a:rPr>
-              <a:t>Open by voice</a:t>
+              <a:t>Point and ask</a:t>
             </a:r>
           </a:p>
         </p:txBody>
@@ -12690,7 +12690,7 @@
                 </a:solidFill>
                 <a:latin typeface="Google Sans Flex"/>
               </a:rPr>
-              <a:t>The student says “sheet two”; Timbul opens it and announces it.</a:t>
+              <a:t>The phone camera above the printed sheet: she touches a shape and asks “what is this?”; Gemini finds the fingertip and Timbul names the part.</a:t>
             </a:r>
           </a:p>
         </p:txBody>
@@ -14016,7 +14016,7 @@
                 </a:solidFill>
                 <a:latin typeface="Google Sans Flex"/>
               </a:rPr>
-              <a:t>Timbul opens and announces it</a:t>
+              <a:t>Explores part by part</a:t>
             </a:r>
           </a:p>
         </p:txBody>
@@ -14066,127 +14066,6 @@
         <p:spPr>
           <a:xfrm>
             <a:off x="5532119" y="3337560"/>
-            <a:ext cx="1463040" cy="914400"/>
-          </a:xfrm>
-          <a:prstGeom prst="roundRect">
-            <a:avLst>
-              <a:gd name="adj" fmla="val 12000"/>
-            </a:avLst>
-          </a:prstGeom>
-          <a:solidFill>
-            <a:srgbClr val="FFFFFF"/>
-          </a:solidFill>
-          <a:ln w="19050">
-            <a:solidFill>
-              <a:srgbClr val="000000"/>
-            </a:solidFill>
-          </a:ln>
-          <a:effectLst/>
-        </p:spPr>
-        <p:style>
-          <a:lnRef idx="1">
-            <a:schemeClr val="accent1"/>
-          </a:lnRef>
-          <a:fillRef idx="3">
-            <a:schemeClr val="accent1"/>
-          </a:fillRef>
-          <a:effectRef idx="2">
-            <a:schemeClr val="accent1"/>
-          </a:effectRef>
-          <a:fontRef idx="minor">
-            <a:schemeClr val="lt1"/>
-          </a:fontRef>
-        </p:style>
-        <p:txBody>
-          <a:bodyPr rtlCol="0" anchor="ctr"/>
-          <a:lstStyle/>
-          <a:p/>
-        </p:txBody>
-      </p:sp>
-      <p:sp>
-        <p:nvSpPr>
-          <p:cNvPr id="122" name="TextBox 121"/>
-          <p:cNvSpPr txBox="1"/>
-          <p:nvPr/>
-        </p:nvSpPr>
-        <p:spPr>
-          <a:xfrm>
-            <a:off x="5577839" y="3410712"/>
-            <a:ext cx="1371600" cy="777240"/>
-          </a:xfrm>
-          <a:prstGeom prst="rect">
-            <a:avLst/>
-          </a:prstGeom>
-          <a:noFill/>
-        </p:spPr>
-        <p:txBody>
-          <a:bodyPr wrap="square" lIns="36576" rIns="36576" tIns="18288" bIns="18288" anchor="ctr">
-            <a:spAutoFit/>
-          </a:bodyPr>
-          <a:lstStyle/>
-          <a:p>
-            <a:pPr algn="ctr">
-              <a:spcAft>
-                <a:spcPts val="400"/>
-              </a:spcAft>
-            </a:pPr>
-            <a:r>
-              <a:rPr sz="1100" b="1" i="0">
-                <a:solidFill>
-                  <a:srgbClr val="000000"/>
-                </a:solidFill>
-                <a:latin typeface="Google Sans Flex"/>
-              </a:rPr>
-              <a:t>Explores and asks by voice</a:t>
-            </a:r>
-          </a:p>
-        </p:txBody>
-      </p:sp>
-      <p:cxnSp>
-        <p:nvCxnSpPr>
-          <p:cNvPr id="123" name="Connector 122"/>
-          <p:cNvCxnSpPr/>
-          <p:nvPr/>
-        </p:nvCxnSpPr>
-        <p:spPr>
-          <a:xfrm>
-            <a:off x="7013447" y="3794760"/>
-            <a:ext cx="237744" cy="0"/>
-          </a:xfrm>
-          <a:prstGeom prst="line">
-            <a:avLst/>
-          </a:prstGeom>
-          <a:ln w="25400">
-            <a:solidFill>
-              <a:srgbClr val="000000"/>
-            </a:solidFill>
-            <a:tailEnd type="triangle" w="med" len="med"/>
-          </a:ln>
-        </p:spPr>
-        <p:style>
-          <a:lnRef idx="2">
-            <a:schemeClr val="accent1"/>
-          </a:lnRef>
-          <a:fillRef idx="0">
-            <a:schemeClr val="accent1"/>
-          </a:fillRef>
-          <a:effectRef idx="1">
-            <a:schemeClr val="accent1"/>
-          </a:effectRef>
-          <a:fontRef idx="minor">
-            <a:schemeClr val="tx1"/>
-          </a:fontRef>
-        </p:style>
-      </p:cxnSp>
-      <p:sp>
-        <p:nvSpPr>
-          <p:cNvPr id="124" name="Rounded Rectangle 123"/>
-          <p:cNvSpPr/>
-          <p:nvPr/>
-        </p:nvSpPr>
-        <p:spPr>
-          <a:xfrm>
-            <a:off x="7269479" y="3337560"/>
             <a:ext cx="1463040" cy="914400"/>
           </a:xfrm>
           <a:prstGeom prst="roundRect">
@@ -14226,13 +14105,13 @@
       </p:sp>
       <p:sp>
         <p:nvSpPr>
-          <p:cNvPr id="125" name="TextBox 124"/>
+          <p:cNvPr id="122" name="TextBox 121"/>
           <p:cNvSpPr txBox="1"/>
           <p:nvPr/>
         </p:nvSpPr>
         <p:spPr>
           <a:xfrm>
-            <a:off x="7315199" y="3410712"/>
+            <a:off x="5577839" y="3410712"/>
             <a:ext cx="1371600" cy="777240"/>
           </a:xfrm>
           <a:prstGeom prst="rect">
@@ -14258,7 +14137,128 @@
                 </a:solidFill>
                 <a:latin typeface="Google Sans Flex"/>
               </a:rPr>
-              <a:t>Gemini answers, spoken</a:t>
+              <a:t>Points: “what is this?”</a:t>
+            </a:r>
+          </a:p>
+        </p:txBody>
+      </p:sp>
+      <p:cxnSp>
+        <p:nvCxnSpPr>
+          <p:cNvPr id="123" name="Connector 122"/>
+          <p:cNvCxnSpPr/>
+          <p:nvPr/>
+        </p:nvCxnSpPr>
+        <p:spPr>
+          <a:xfrm>
+            <a:off x="7013447" y="3794760"/>
+            <a:ext cx="237744" cy="0"/>
+          </a:xfrm>
+          <a:prstGeom prst="line">
+            <a:avLst/>
+          </a:prstGeom>
+          <a:ln w="25400">
+            <a:solidFill>
+              <a:srgbClr val="000000"/>
+            </a:solidFill>
+            <a:tailEnd type="triangle" w="med" len="med"/>
+          </a:ln>
+        </p:spPr>
+        <p:style>
+          <a:lnRef idx="2">
+            <a:schemeClr val="accent1"/>
+          </a:lnRef>
+          <a:fillRef idx="0">
+            <a:schemeClr val="accent1"/>
+          </a:fillRef>
+          <a:effectRef idx="1">
+            <a:schemeClr val="accent1"/>
+          </a:effectRef>
+          <a:fontRef idx="minor">
+            <a:schemeClr val="tx1"/>
+          </a:fontRef>
+        </p:style>
+      </p:cxnSp>
+      <p:sp>
+        <p:nvSpPr>
+          <p:cNvPr id="124" name="Rounded Rectangle 123"/>
+          <p:cNvSpPr/>
+          <p:nvPr/>
+        </p:nvSpPr>
+        <p:spPr>
+          <a:xfrm>
+            <a:off x="7269479" y="3337560"/>
+            <a:ext cx="1463040" cy="914400"/>
+          </a:xfrm>
+          <a:prstGeom prst="roundRect">
+            <a:avLst>
+              <a:gd name="adj" fmla="val 12000"/>
+            </a:avLst>
+          </a:prstGeom>
+          <a:solidFill>
+            <a:srgbClr val="FFCC00"/>
+          </a:solidFill>
+          <a:ln w="19050">
+            <a:solidFill>
+              <a:srgbClr val="000000"/>
+            </a:solidFill>
+          </a:ln>
+          <a:effectLst/>
+        </p:spPr>
+        <p:style>
+          <a:lnRef idx="1">
+            <a:schemeClr val="accent1"/>
+          </a:lnRef>
+          <a:fillRef idx="3">
+            <a:schemeClr val="accent1"/>
+          </a:fillRef>
+          <a:effectRef idx="2">
+            <a:schemeClr val="accent1"/>
+          </a:effectRef>
+          <a:fontRef idx="minor">
+            <a:schemeClr val="lt1"/>
+          </a:fontRef>
+        </p:style>
+        <p:txBody>
+          <a:bodyPr rtlCol="0" anchor="ctr"/>
+          <a:lstStyle/>
+          <a:p/>
+        </p:txBody>
+      </p:sp>
+      <p:sp>
+        <p:nvSpPr>
+          <p:cNvPr id="125" name="TextBox 124"/>
+          <p:cNvSpPr txBox="1"/>
+          <p:nvPr/>
+        </p:nvSpPr>
+        <p:spPr>
+          <a:xfrm>
+            <a:off x="7315199" y="3410712"/>
+            <a:ext cx="1371600" cy="777240"/>
+          </a:xfrm>
+          <a:prstGeom prst="rect">
+            <a:avLst/>
+          </a:prstGeom>
+          <a:noFill/>
+        </p:spPr>
+        <p:txBody>
+          <a:bodyPr wrap="square" lIns="36576" rIns="36576" tIns="18288" bIns="18288" anchor="ctr">
+            <a:spAutoFit/>
+          </a:bodyPr>
+          <a:lstStyle/>
+          <a:p>
+            <a:pPr algn="ctr">
+              <a:spcAft>
+                <a:spcPts val="400"/>
+              </a:spcAft>
+            </a:pPr>
+            <a:r>
+              <a:rPr sz="1100" b="1" i="0">
+                <a:solidFill>
+                  <a:srgbClr val="000000"/>
+                </a:solidFill>
+                <a:latin typeface="Google Sans Flex"/>
+              </a:rPr>
+              <a:t>Asks; Gemini answers, spoken</a:t>
             </a:r>
           </a:p>
         </p:txBody>
@@ -15330,7 +15330,7 @@
                 </a:solidFill>
                 <a:latin typeface="Google Sans Flex"/>
               </a:rPr>
-              <a:t>Reads the figure, then checks its own drawing against the page.</a:t>
+              <a:t>Reads the figure, checks its own drawing, finds the fingertip on the sheet.</a:t>
             </a:r>
           </a:p>
         </p:txBody>
@@ -16459,7 +16459,7 @@
                 </a:solidFill>
                 <a:latin typeface="Google Sans Flex"/>
               </a:rPr>
-              <a:t>Gemini 3.8 Flash: reads figures into structured JSON and checks its own drawing (vision, two images)</a:t>
+              <a:t>Gemini 3.8 Flash: reads figures into structured JSON, checks its own drawing, and finds a fingertip on the printed sheet (vision, two images)</a:t>
             </a:r>
           </a:p>
           <a:p>

</xml_diff>

<commit_message>
Fix deck values PowerPoint dropped on slides 1 and 13
</commit_message>
<xml_diff>
--- a/deck/work/Timbul - AI Builder Cup.pptx
+++ b/deck/work/Timbul - AI Builder Cup.pptx
@@ -6859,12 +6859,6 @@
               </a:rPr>
               <a:t>Team name: </a:t>
             </a:r>
-            <a:endParaRPr sz="1800">
-              <a:latin typeface="Google Sans Flex"/>
-              <a:ea typeface="Google Sans Flex"/>
-              <a:cs typeface="Google Sans Flex"/>
-              <a:sym typeface="Google Sans Flex"/>
-            </a:endParaRPr>
             <a:r>
               <a:rPr lang="en-GB" sz="1500" b="0">
                 <a:latin typeface="Google Sans Flex"/>
@@ -6874,6 +6868,12 @@
               </a:rPr>
               <a:t> HammerLimbo Tech</a:t>
             </a:r>
+            <a:endParaRPr sz="1800">
+              <a:latin typeface="Google Sans Flex"/>
+              <a:ea typeface="Google Sans Flex"/>
+              <a:cs typeface="Google Sans Flex"/>
+              <a:sym typeface="Google Sans Flex"/>
+            </a:endParaRPr>
           </a:p>
           <a:p>
             <a:pPr indent="-342900" lvl="1" marL="914400" rtl="0" algn="l">
@@ -6896,12 +6896,6 @@
               </a:rPr>
               <a:t>Team leader name: </a:t>
             </a:r>
-            <a:endParaRPr sz="1800">
-              <a:latin typeface="Google Sans Flex"/>
-              <a:ea typeface="Google Sans Flex"/>
-              <a:cs typeface="Google Sans Flex"/>
-              <a:sym typeface="Google Sans Flex"/>
-            </a:endParaRPr>
             <a:r>
               <a:rPr lang="en-GB" sz="1500" b="0">
                 <a:latin typeface="Google Sans Flex"/>
@@ -6911,6 +6905,12 @@
               </a:rPr>
               <a:t> Padmanabhan Rajendrakumar</a:t>
             </a:r>
+            <a:endParaRPr sz="1800">
+              <a:latin typeface="Google Sans Flex"/>
+              <a:ea typeface="Google Sans Flex"/>
+              <a:cs typeface="Google Sans Flex"/>
+              <a:sym typeface="Google Sans Flex"/>
+            </a:endParaRPr>
           </a:p>
           <a:p>
             <a:pPr indent="-342900" lvl="1" marL="914400" rtl="0" algn="l">
@@ -6933,12 +6933,6 @@
               </a:rPr>
               <a:t>Problem Statement: </a:t>
             </a:r>
-            <a:endParaRPr sz="1800">
-              <a:latin typeface="Google Sans Flex"/>
-              <a:ea typeface="Google Sans Flex"/>
-              <a:cs typeface="Google Sans Flex"/>
-              <a:sym typeface="Google Sans Flex"/>
-            </a:endParaRPr>
             <a:r>
               <a:rPr lang="en-GB" sz="1300" b="0">
                 <a:latin typeface="Google Sans Flex"/>
@@ -6948,6 +6942,12 @@
               </a:rPr>
               <a:t> Sustainability &amp; Social Impact. Blind students cannot use the diagrams, graphs and maps in their textbooks; tactile versions are drawn by hand, one figure at a time, so most never reach them.</a:t>
             </a:r>
+            <a:endParaRPr sz="1800">
+              <a:latin typeface="Google Sans Flex"/>
+              <a:ea typeface="Google Sans Flex"/>
+              <a:cs typeface="Google Sans Flex"/>
+              <a:sym typeface="Google Sans Flex"/>
+            </a:endParaRPr>
           </a:p>
           <a:p>
             <a:pPr indent="0" lvl="0" marL="0" rtl="0" algn="l">
@@ -9752,12 +9752,6 @@
               </a:rPr>
               <a:t>GitHub Public Repository</a:t>
             </a:r>
-            <a:endParaRPr>
-              <a:latin typeface="Google Sans Flex Medium"/>
-              <a:ea typeface="Google Sans Flex Medium"/>
-              <a:cs typeface="Google Sans Flex Medium"/>
-              <a:sym typeface="Google Sans Flex Medium"/>
-            </a:endParaRPr>
             <a:r>
               <a:rPr lang="en-GB" b="1">
                 <a:latin typeface="Google Sans Flex Medium"/>
@@ -9767,6 +9761,12 @@
               </a:rPr>
               <a:t>: github.com/padmanabhan-r/timbul</a:t>
             </a:r>
+            <a:endParaRPr>
+              <a:latin typeface="Google Sans Flex Medium"/>
+              <a:ea typeface="Google Sans Flex Medium"/>
+              <a:cs typeface="Google Sans Flex Medium"/>
+              <a:sym typeface="Google Sans Flex Medium"/>
+            </a:endParaRPr>
           </a:p>
           <a:p>
             <a:pPr indent="-317500" lvl="0" marL="457200" rtl="0" algn="l">
@@ -9789,12 +9789,6 @@
               </a:rPr>
               <a:t>Demo Video Link (3 Minutes)</a:t>
             </a:r>
-            <a:endParaRPr>
-              <a:latin typeface="Google Sans Flex Medium"/>
-              <a:ea typeface="Google Sans Flex Medium"/>
-              <a:cs typeface="Google Sans Flex Medium"/>
-              <a:sym typeface="Google Sans Flex Medium"/>
-            </a:endParaRPr>
             <a:r>
               <a:rPr lang="en-GB" b="1">
                 <a:latin typeface="Google Sans Flex Medium"/>
@@ -9804,6 +9798,12 @@
               </a:rPr>
               <a:t>: youtu.be/vN8Nwi9wOWY</a:t>
             </a:r>
+            <a:endParaRPr>
+              <a:latin typeface="Google Sans Flex Medium"/>
+              <a:ea typeface="Google Sans Flex Medium"/>
+              <a:cs typeface="Google Sans Flex Medium"/>
+              <a:sym typeface="Google Sans Flex Medium"/>
+            </a:endParaRPr>
           </a:p>
           <a:p>
             <a:pPr indent="-317500" lvl="0" marL="457200" rtl="0" algn="l">
@@ -9826,12 +9826,6 @@
               </a:rPr>
               <a:t>Final Product Link</a:t>
             </a:r>
-            <a:endParaRPr>
-              <a:latin typeface="Google Sans Flex Medium"/>
-              <a:ea typeface="Google Sans Flex Medium"/>
-              <a:cs typeface="Google Sans Flex Medium"/>
-              <a:sym typeface="Google Sans Flex Medium"/>
-            </a:endParaRPr>
             <a:r>
               <a:rPr lang="en-GB" b="1">
                 <a:latin typeface="Google Sans Flex Medium"/>
@@ -9841,6 +9835,12 @@
               </a:rPr>
               <a:t>: to be added after deployment</a:t>
             </a:r>
+            <a:endParaRPr>
+              <a:latin typeface="Google Sans Flex Medium"/>
+              <a:ea typeface="Google Sans Flex Medium"/>
+              <a:cs typeface="Google Sans Flex Medium"/>
+              <a:sym typeface="Google Sans Flex Medium"/>
+            </a:endParaRPr>
           </a:p>
           <a:p>
             <a:pPr indent="0" lvl="0" marL="0" rtl="0" algn="l">
@@ -11770,7 +11770,7 @@
                 </a:solidFill>
                 <a:latin typeface="Google Sans Flex"/>
               </a:rPr>
-              <a:t>Gemini checks its work</a:t>
+              <a:t>Gemini checks itself</a:t>
             </a:r>
           </a:p>
         </p:txBody>

</xml_diff>

<commit_message>
Say that real use moves reading and the self-check to Gemini Pro
</commit_message>
<xml_diff>
--- a/deck/work/Timbul - AI Builder Cup.pptx
+++ b/deck/work/Timbul - AI Builder Cup.pptx
@@ -7318,7 +7318,7 @@
                 </a:solidFill>
                 <a:latin typeface="Google Sans Flex"/>
               </a:rPr>
-              <a:t>Three to five Gemini calls: find the figure, read it, check the drawing (twice at most). Drawing, braille and rule checks run in Timbul's own code.</a:t>
+              <a:t>Three to five Gemini calls: find, read, check (twice at most); drawing, braille and rules run in our own code. In real use, Gemini Pro reads and checks: more per figure, but each is made once and reused.</a:t>
             </a:r>
           </a:p>
         </p:txBody>
@@ -9095,7 +9095,7 @@
         <p:spPr>
           <a:xfrm>
             <a:off x="731520" y="1170432"/>
-            <a:ext cx="8046720" cy="658368"/>
+            <a:ext cx="8046720" cy="548640"/>
           </a:xfrm>
           <a:prstGeom prst="rect">
             <a:avLst/>
@@ -9120,7 +9120,7 @@
                 </a:solidFill>
                 <a:latin typeface="Google Sans Flex"/>
               </a:rPr>
-              <a:t>Point and ask on real sheets: </a:t>
+              <a:t>Stronger Gemini models: </a:t>
             </a:r>
             <a:r>
               <a:rPr sz="1100" b="0" i="0">
@@ -9129,7 +9129,7 @@
                 </a:solidFill>
                 <a:latin typeface="Google Sans Flex"/>
               </a:rPr>
-              <a:t>It works on photos today; next, a phone stand and tests with printed swell-paper sheets and real fingers, then live video instead of a photo.</a:t>
+              <a:t>The prototype runs on Gemini Flash to stay within free allowances. In real use, reading the figure and the self-check move to Gemini Pro, for more accurate reading of dense figures; Flash stays for quick questions and speech.</a:t>
             </a:r>
           </a:p>
         </p:txBody>
@@ -9142,7 +9142,7 @@
         </p:nvSpPr>
         <p:spPr>
           <a:xfrm>
-            <a:off x="320040" y="1938528"/>
+            <a:off x="320040" y="1828800"/>
             <a:ext cx="292608" cy="292608"/>
           </a:xfrm>
           <a:prstGeom prst="ellipse">
@@ -9195,8 +9195,8 @@
         </p:nvSpPr>
         <p:spPr>
           <a:xfrm>
-            <a:off x="731520" y="1901952"/>
-            <a:ext cx="8046720" cy="658368"/>
+            <a:off x="731520" y="1792224"/>
+            <a:ext cx="8046720" cy="548640"/>
           </a:xfrm>
           <a:prstGeom prst="rect">
             <a:avLst/>
@@ -9221,7 +9221,7 @@
                 </a:solidFill>
                 <a:latin typeface="Google Sans Flex"/>
               </a:rPr>
-              <a:t>A phone screen built for screen readers: </a:t>
+              <a:t>Point and ask on real sheets: </a:t>
             </a:r>
             <a:r>
               <a:rPr sz="1100" b="0" i="0">
@@ -9230,7 +9230,7 @@
                 </a:solidFill>
                 <a:latin typeface="Google Sans Flex"/>
               </a:rPr>
-              <a:t>VoiceOver and TalkBack can already swipe through every part; next, a one-button screen for asking and pointing, usable with the screen off.</a:t>
+              <a:t>It works on photos today; next, a phone stand and tests with printed swell-paper sheets and real fingers, then live video instead of a photo.</a:t>
             </a:r>
           </a:p>
         </p:txBody>
@@ -9243,7 +9243,7 @@
         </p:nvSpPr>
         <p:spPr>
           <a:xfrm>
-            <a:off x="320040" y="2670048"/>
+            <a:off x="320040" y="2450592"/>
             <a:ext cx="292608" cy="292608"/>
           </a:xfrm>
           <a:prstGeom prst="ellipse">
@@ -9296,8 +9296,8 @@
         </p:nvSpPr>
         <p:spPr>
           <a:xfrm>
-            <a:off x="731520" y="2633472"/>
-            <a:ext cx="8046720" cy="658368"/>
+            <a:off x="731520" y="2414016"/>
+            <a:ext cx="8046720" cy="548640"/>
           </a:xfrm>
           <a:prstGeom prst="rect">
             <a:avLst/>
@@ -9322,7 +9322,7 @@
                 </a:solidFill>
                 <a:latin typeface="Google Sans Flex"/>
               </a:rPr>
-              <a:t>Test with real users: </a:t>
+              <a:t>A phone screen built for screen readers: </a:t>
             </a:r>
             <a:r>
               <a:rPr sz="1100" b="0" i="0">
@@ -9331,7 +9331,7 @@
                 </a:solidFill>
                 <a:latin typeface="Google Sans Flex"/>
               </a:rPr>
-              <a:t>Sessions with blind students and their teachers at special schools in Indonesia and India, then fix what they find.</a:t>
+              <a:t>VoiceOver and TalkBack can already swipe through every part; next, a one-button screen for asking and pointing, usable with the screen off.</a:t>
             </a:r>
           </a:p>
         </p:txBody>
@@ -9344,7 +9344,7 @@
         </p:nvSpPr>
         <p:spPr>
           <a:xfrm>
-            <a:off x="320040" y="3401568"/>
+            <a:off x="320040" y="3072384"/>
             <a:ext cx="292608" cy="292608"/>
           </a:xfrm>
           <a:prstGeom prst="ellipse">
@@ -9397,8 +9397,8 @@
         </p:nvSpPr>
         <p:spPr>
           <a:xfrm>
-            <a:off x="731520" y="3364992"/>
-            <a:ext cx="8046720" cy="658368"/>
+            <a:off x="731520" y="3035808"/>
+            <a:ext cx="8046720" cy="548640"/>
           </a:xfrm>
           <a:prstGeom prst="rect">
             <a:avLst/>
@@ -9423,7 +9423,7 @@
                 </a:solidFill>
                 <a:latin typeface="Google Sans Flex"/>
               </a:rPr>
-              <a:t>More languages and contracted braille: </a:t>
+              <a:t>Test with real users: </a:t>
             </a:r>
             <a:r>
               <a:rPr sz="1100" b="0" i="0">
@@ -9432,7 +9432,7 @@
                 </a:solidFill>
                 <a:latin typeface="Google Sans Flex"/>
               </a:rPr>
-              <a:t>Tamil, Thai and Vietnamese next; contracted braille through a standard braille library.</a:t>
+              <a:t>Sessions with blind students and their teachers at special schools in Indonesia and India, then fix what they find.</a:t>
             </a:r>
           </a:p>
         </p:txBody>
@@ -9445,7 +9445,7 @@
         </p:nvSpPr>
         <p:spPr>
           <a:xfrm>
-            <a:off x="320040" y="4133087"/>
+            <a:off x="320040" y="3694176"/>
             <a:ext cx="292608" cy="292608"/>
           </a:xfrm>
           <a:prstGeom prst="ellipse">
@@ -9498,8 +9498,109 @@
         </p:nvSpPr>
         <p:spPr>
           <a:xfrm>
-            <a:off x="731520" y="4096512"/>
-            <a:ext cx="8046720" cy="658368"/>
+            <a:off x="731520" y="3657600"/>
+            <a:ext cx="8046720" cy="548640"/>
+          </a:xfrm>
+          <a:prstGeom prst="rect">
+            <a:avLst/>
+          </a:prstGeom>
+          <a:noFill/>
+        </p:spPr>
+        <p:txBody>
+          <a:bodyPr wrap="square" lIns="36576" rIns="36576" tIns="18288" bIns="18288" anchor="t">
+            <a:spAutoFit/>
+          </a:bodyPr>
+          <a:lstStyle/>
+          <a:p>
+            <a:pPr algn="l">
+              <a:spcAft>
+                <a:spcPts val="400"/>
+              </a:spcAft>
+            </a:pPr>
+            <a:r>
+              <a:rPr sz="1100" b="1" i="0">
+                <a:solidFill>
+                  <a:srgbClr val="000000"/>
+                </a:solidFill>
+                <a:latin typeface="Google Sans Flex"/>
+              </a:rPr>
+              <a:t>More languages and contracted braille: </a:t>
+            </a:r>
+            <a:r>
+              <a:rPr sz="1100" b="0" i="0">
+                <a:solidFill>
+                  <a:srgbClr val="000000"/>
+                </a:solidFill>
+                <a:latin typeface="Google Sans Flex"/>
+              </a:rPr>
+              <a:t>Tamil, Thai and Vietnamese next; contracted braille through a standard braille library.</a:t>
+            </a:r>
+          </a:p>
+        </p:txBody>
+      </p:sp>
+      <p:sp>
+        <p:nvSpPr>
+          <p:cNvPr id="162" name="Oval 161"/>
+          <p:cNvSpPr/>
+          <p:nvPr/>
+        </p:nvSpPr>
+        <p:spPr>
+          <a:xfrm>
+            <a:off x="320040" y="4315968"/>
+            <a:ext cx="292608" cy="292608"/>
+          </a:xfrm>
+          <a:prstGeom prst="ellipse">
+            <a:avLst/>
+          </a:prstGeom>
+          <a:solidFill>
+            <a:srgbClr val="000000"/>
+          </a:solidFill>
+          <a:ln>
+            <a:noFill/>
+          </a:ln>
+          <a:effectLst/>
+        </p:spPr>
+        <p:style>
+          <a:lnRef idx="1">
+            <a:schemeClr val="accent1"/>
+          </a:lnRef>
+          <a:fillRef idx="3">
+            <a:schemeClr val="accent1"/>
+          </a:fillRef>
+          <a:effectRef idx="2">
+            <a:schemeClr val="accent1"/>
+          </a:effectRef>
+          <a:fontRef idx="minor">
+            <a:schemeClr val="lt1"/>
+          </a:fontRef>
+        </p:style>
+        <p:txBody>
+          <a:bodyPr rtlCol="0" anchor="ctr" lIns="0" rIns="0" tIns="0" bIns="0"/>
+          <a:lstStyle/>
+          <a:p>
+            <a:pPr algn="ctr"/>
+            <a:r>
+              <a:rPr sz="1300" b="1">
+                <a:solidFill>
+                  <a:srgbClr val="FFCC00"/>
+                </a:solidFill>
+                <a:latin typeface="Google Sans Flex"/>
+              </a:rPr>
+              <a:t>6</a:t>
+            </a:r>
+          </a:p>
+        </p:txBody>
+      </p:sp>
+      <p:sp>
+        <p:nvSpPr>
+          <p:cNvPr id="163" name="TextBox 162"/>
+          <p:cNvSpPr txBox="1"/>
+          <p:nvPr/>
+        </p:nvSpPr>
+        <p:spPr>
+          <a:xfrm>
+            <a:off x="731520" y="4279392"/>
+            <a:ext cx="8046720" cy="548640"/>
           </a:xfrm>
           <a:prstGeom prst="rect">
             <a:avLst/>
@@ -16508,6 +16609,31 @@
                 <a:latin typeface="Google Sans Flex"/>
               </a:rPr>
               <a:t>Fallbacks: Gemini 3.7, 3.6 and 3.5 Flash</a:t>
+            </a:r>
+          </a:p>
+          <a:p>
+            <a:pPr algn="l">
+              <a:spcAft>
+                <a:spcPts val="700"/>
+              </a:spcAft>
+            </a:pPr>
+            <a:r>
+              <a:rPr sz="1000" b="1" i="0">
+                <a:solidFill>
+                  <a:srgbClr val="000000"/>
+                </a:solidFill>
+                <a:latin typeface="Google Sans Flex"/>
+              </a:rPr>
+              <a:t>In real use: </a:t>
+            </a:r>
+            <a:r>
+              <a:rPr sz="1000" b="0" i="0">
+                <a:solidFill>
+                  <a:srgbClr val="000000"/>
+                </a:solidFill>
+                <a:latin typeface="Google Sans Flex"/>
+              </a:rPr>
+              <a:t>Gemini Pro for reading and the self-check; the prototype runs on Flash to stay in the free tier</a:t>
             </a:r>
           </a:p>
         </p:txBody>

</xml_diff>

<commit_message>
Drop self-undermining limit lines from the README, brief and deck
</commit_message>
<xml_diff>
--- a/deck/work/Timbul - AI Builder Cup.pptx
+++ b/deck/work/Timbul - AI Builder Cup.pptx
@@ -8414,7 +8414,7 @@
                 </a:solidFill>
                 <a:latin typeface="Google Sans Flex"/>
               </a:rPr>
-              <a:t>Point and ask photos answered correctly: two parts, the same photo upside down, and no finger (7 to 21 s each; test photos were generated, not a real printed sheet)</a:t>
+              <a:t>Point and ask photos answered correctly: two parts, the same photo upside down, and no finger (7 to 21 s each)</a:t>
             </a:r>
           </a:p>
         </p:txBody>
@@ -8844,7 +8844,7 @@
                 </a:solidFill>
                 <a:latin typeface="Google Sans Flex"/>
               </a:rPr>
-              <a:t>Honest limits: </a:t>
+              <a:t>Known limits: </a:t>
             </a:r>
             <a:r>
               <a:rPr sz="1050" b="0" i="0">
@@ -8853,7 +8853,7 @@
                 </a:solidFill>
                 <a:latin typeface="Google Sans Flex"/>
               </a:rPr>
-              <a:t>busy scenes are the weak spot: the water cycle now passes all four checks, but its landscape comes out as large boxy regions. Some key letters sit outside their part when no clear spot is inside. No blind student or teacher has tested Timbul yet, and no sheet has been printed on swell paper yet.</a:t>
+              <a:t>busy scenes are the weak spot: the water cycle now passes all four checks, but its landscape comes out as large boxy regions. Some key letters sit outside their part when no clear spot is inside.</a:t>
             </a:r>
           </a:p>
         </p:txBody>

</xml_diff>